<commit_message>
data-eng decks — 단계 번호 뒤 점(30덱) + bundles
Co-Authored-By: Claude Opus 5.5 <noreply@anthropic.com>
</commit_message>
<xml_diff>
--- a/data-eng/decks/w1d2s2.pptx
+++ b/data-eng/decks/w1d2s2.pptx
@@ -3100,7 +3100,7 @@
       <p:grpSpPr/>
       <p:sp>
         <p:nvSpPr>
-          <p:cNvPr id="2" name="Oval 1"/>
+          <p:cNvPr id="2" name="deckgen:decor"/>
           <p:cNvSpPr/>
           <p:nvPr/>
         </p:nvSpPr>
@@ -3130,7 +3130,7 @@
       </p:sp>
       <p:sp>
         <p:nvSpPr>
-          <p:cNvPr id="3" name="Oval 2"/>
+          <p:cNvPr id="3" name="deckgen:decor"/>
           <p:cNvSpPr/>
           <p:nvPr/>
         </p:nvSpPr>
@@ -3160,7 +3160,7 @@
       </p:sp>
       <p:sp>
         <p:nvSpPr>
-          <p:cNvPr id="4" name="Oval 3"/>
+          <p:cNvPr id="4" name="deckgen:decor"/>
           <p:cNvSpPr/>
           <p:nvPr/>
         </p:nvSpPr>
@@ -3190,7 +3190,7 @@
       </p:sp>
       <p:sp>
         <p:nvSpPr>
-          <p:cNvPr id="5" name="Rectangle 4"/>
+          <p:cNvPr id="5" name="deckgen:decor"/>
           <p:cNvSpPr/>
           <p:nvPr/>
         </p:nvSpPr>
@@ -3220,7 +3220,7 @@
       </p:sp>
       <p:sp>
         <p:nvSpPr>
-          <p:cNvPr id="6" name="Oval 5"/>
+          <p:cNvPr id="6" name="deckgen:decor"/>
           <p:cNvSpPr/>
           <p:nvPr/>
         </p:nvSpPr>
@@ -3250,7 +3250,7 @@
       </p:sp>
       <p:sp>
         <p:nvSpPr>
-          <p:cNvPr id="7" name="Oval 6"/>
+          <p:cNvPr id="7" name="deckgen:decor"/>
           <p:cNvSpPr/>
           <p:nvPr/>
         </p:nvSpPr>
@@ -3280,7 +3280,7 @@
       </p:sp>
       <p:sp>
         <p:nvSpPr>
-          <p:cNvPr id="8" name="Oval 7"/>
+          <p:cNvPr id="8" name="deckgen:decor"/>
           <p:cNvSpPr/>
           <p:nvPr/>
         </p:nvSpPr>
@@ -3310,7 +3310,7 @@
       </p:sp>
       <p:sp>
         <p:nvSpPr>
-          <p:cNvPr id="9" name="Oval 8"/>
+          <p:cNvPr id="9" name="deckgen:decor"/>
           <p:cNvSpPr/>
           <p:nvPr/>
         </p:nvSpPr>
@@ -3340,7 +3340,7 @@
       </p:sp>
       <p:sp>
         <p:nvSpPr>
-          <p:cNvPr id="10" name="Rectangle 9"/>
+          <p:cNvPr id="10" name="deckgen:decor"/>
           <p:cNvSpPr/>
           <p:nvPr/>
         </p:nvSpPr>
@@ -3600,7 +3600,7 @@
       <p:grpSpPr/>
       <p:sp>
         <p:nvSpPr>
-          <p:cNvPr id="2" name="Oval 1"/>
+          <p:cNvPr id="2" name="deckgen:decor"/>
           <p:cNvSpPr/>
           <p:nvPr/>
         </p:nvSpPr>
@@ -3630,7 +3630,7 @@
       </p:sp>
       <p:sp>
         <p:nvSpPr>
-          <p:cNvPr id="3" name="Oval 2"/>
+          <p:cNvPr id="3" name="deckgen:decor"/>
           <p:cNvSpPr/>
           <p:nvPr/>
         </p:nvSpPr>
@@ -3660,7 +3660,7 @@
       </p:sp>
       <p:sp>
         <p:nvSpPr>
-          <p:cNvPr id="4" name="Oval 3"/>
+          <p:cNvPr id="4" name="deckgen:decor"/>
           <p:cNvSpPr/>
           <p:nvPr/>
         </p:nvSpPr>
@@ -4808,7 +4808,7 @@
       <p:grpSpPr/>
       <p:sp>
         <p:nvSpPr>
-          <p:cNvPr id="2" name="Oval 1"/>
+          <p:cNvPr id="2" name="deckgen:decor"/>
           <p:cNvSpPr/>
           <p:nvPr/>
         </p:nvSpPr>
@@ -4838,7 +4838,7 @@
       </p:sp>
       <p:sp>
         <p:nvSpPr>
-          <p:cNvPr id="3" name="Oval 2"/>
+          <p:cNvPr id="3" name="deckgen:decor"/>
           <p:cNvSpPr/>
           <p:nvPr/>
         </p:nvSpPr>
@@ -5615,7 +5615,7 @@
       <p:grpSpPr/>
       <p:sp>
         <p:nvSpPr>
-          <p:cNvPr id="2" name="Oval 1"/>
+          <p:cNvPr id="2" name="deckgen:decor"/>
           <p:cNvSpPr/>
           <p:nvPr/>
         </p:nvSpPr>
@@ -5645,7 +5645,7 @@
       </p:sp>
       <p:sp>
         <p:nvSpPr>
-          <p:cNvPr id="3" name="Oval 2"/>
+          <p:cNvPr id="3" name="deckgen:decor"/>
           <p:cNvSpPr/>
           <p:nvPr/>
         </p:nvSpPr>
@@ -5675,7 +5675,7 @@
       </p:sp>
       <p:sp>
         <p:nvSpPr>
-          <p:cNvPr id="4" name="Oval 3"/>
+          <p:cNvPr id="4" name="deckgen:decor"/>
           <p:cNvSpPr/>
           <p:nvPr/>
         </p:nvSpPr>
@@ -6606,7 +6606,7 @@
       <p:grpSpPr/>
       <p:sp>
         <p:nvSpPr>
-          <p:cNvPr id="2" name="Oval 1"/>
+          <p:cNvPr id="2" name="deckgen:decor"/>
           <p:cNvSpPr/>
           <p:nvPr/>
         </p:nvSpPr>
@@ -6636,7 +6636,7 @@
       </p:sp>
       <p:sp>
         <p:nvSpPr>
-          <p:cNvPr id="3" name="Oval 2"/>
+          <p:cNvPr id="3" name="deckgen:decor"/>
           <p:cNvSpPr/>
           <p:nvPr/>
         </p:nvSpPr>
@@ -6666,7 +6666,7 @@
       </p:sp>
       <p:sp>
         <p:nvSpPr>
-          <p:cNvPr id="4" name="Oval 3"/>
+          <p:cNvPr id="4" name="deckgen:decor"/>
           <p:cNvSpPr/>
           <p:nvPr/>
         </p:nvSpPr>
@@ -6947,7 +6947,7 @@
                 <a:ea typeface="Pretendard"/>
                 <a:cs typeface="Pretendard"/>
               </a:rPr>
-              <a:t>1~2 · greet.sh</a:t>
+              <a:t>1~2. greet.sh</a:t>
             </a:r>
           </a:p>
         </p:txBody>
@@ -7093,7 +7093,7 @@
                 <a:ea typeface="Pretendard"/>
                 <a:cs typeface="Pretendard"/>
               </a:rPr>
-              <a:t>3 · 따옴표 실험</a:t>
+              <a:t>3. 따옴표 실험</a:t>
             </a:r>
           </a:p>
         </p:txBody>
@@ -7239,7 +7239,7 @@
                 <a:ea typeface="Pretendard"/>
                 <a:cs typeface="Pretendard"/>
               </a:rPr>
-              <a:t>4~5 · 검사·집계</a:t>
+              <a:t>4~5. 검사·집계</a:t>
             </a:r>
           </a:p>
         </p:txBody>
@@ -7385,7 +7385,7 @@
                 <a:ea typeface="Pretendard"/>
                 <a:cs typeface="Pretendard"/>
               </a:rPr>
-              <a:t>6~9 · 함수·case</a:t>
+              <a:t>6~9. 함수·case</a:t>
             </a:r>
           </a:p>
         </p:txBody>
@@ -7531,7 +7531,7 @@
                 <a:ea typeface="Pretendard"/>
                 <a:cs typeface="Pretendard"/>
               </a:rPr>
-              <a:t>10 · ShellCheck</a:t>
+              <a:t>10. ShellCheck</a:t>
             </a:r>
           </a:p>
         </p:txBody>
@@ -7709,7 +7709,7 @@
       <p:grpSpPr/>
       <p:sp>
         <p:nvSpPr>
-          <p:cNvPr id="2" name="Oval 1"/>
+          <p:cNvPr id="2" name="deckgen:decor"/>
           <p:cNvSpPr/>
           <p:nvPr/>
         </p:nvSpPr>
@@ -7739,7 +7739,7 @@
       </p:sp>
       <p:sp>
         <p:nvSpPr>
-          <p:cNvPr id="3" name="Oval 2"/>
+          <p:cNvPr id="3" name="deckgen:decor"/>
           <p:cNvSpPr/>
           <p:nvPr/>
         </p:nvSpPr>
@@ -7769,7 +7769,7 @@
       </p:sp>
       <p:sp>
         <p:nvSpPr>
-          <p:cNvPr id="4" name="Oval 3"/>
+          <p:cNvPr id="4" name="deckgen:decor"/>
           <p:cNvSpPr/>
           <p:nvPr/>
         </p:nvSpPr>
@@ -8970,7 +8970,7 @@
       <p:grpSpPr/>
       <p:sp>
         <p:nvSpPr>
-          <p:cNvPr id="2" name="Oval 1"/>
+          <p:cNvPr id="2" name="deckgen:decor"/>
           <p:cNvSpPr/>
           <p:nvPr/>
         </p:nvSpPr>
@@ -9000,7 +9000,7 @@
       </p:sp>
       <p:sp>
         <p:nvSpPr>
-          <p:cNvPr id="3" name="Oval 2"/>
+          <p:cNvPr id="3" name="deckgen:decor"/>
           <p:cNvSpPr/>
           <p:nvPr/>
         </p:nvSpPr>
@@ -9030,7 +9030,7 @@
       </p:sp>
       <p:sp>
         <p:nvSpPr>
-          <p:cNvPr id="4" name="Oval 3"/>
+          <p:cNvPr id="4" name="deckgen:decor"/>
           <p:cNvSpPr/>
           <p:nvPr/>
         </p:nvSpPr>
@@ -10173,7 +10173,7 @@
       <p:grpSpPr/>
       <p:sp>
         <p:nvSpPr>
-          <p:cNvPr id="2" name="Oval 1"/>
+          <p:cNvPr id="2" name="deckgen:decor"/>
           <p:cNvSpPr/>
           <p:nvPr/>
         </p:nvSpPr>
@@ -10203,7 +10203,7 @@
       </p:sp>
       <p:sp>
         <p:nvSpPr>
-          <p:cNvPr id="3" name="Oval 2"/>
+          <p:cNvPr id="3" name="deckgen:decor"/>
           <p:cNvSpPr/>
           <p:nvPr/>
         </p:nvSpPr>
@@ -10233,7 +10233,7 @@
       </p:sp>
       <p:sp>
         <p:nvSpPr>
-          <p:cNvPr id="4" name="Oval 3"/>
+          <p:cNvPr id="4" name="deckgen:decor"/>
           <p:cNvSpPr/>
           <p:nvPr/>
         </p:nvSpPr>
@@ -11387,7 +11387,7 @@
       <p:grpSpPr/>
       <p:sp>
         <p:nvSpPr>
-          <p:cNvPr id="2" name="Oval 1"/>
+          <p:cNvPr id="2" name="deckgen:decor"/>
           <p:cNvSpPr/>
           <p:nvPr/>
         </p:nvSpPr>
@@ -11417,7 +11417,7 @@
       </p:sp>
       <p:sp>
         <p:nvSpPr>
-          <p:cNvPr id="3" name="Oval 2"/>
+          <p:cNvPr id="3" name="deckgen:decor"/>
           <p:cNvSpPr/>
           <p:nvPr/>
         </p:nvSpPr>
@@ -11447,7 +11447,7 @@
       </p:sp>
       <p:sp>
         <p:nvSpPr>
-          <p:cNvPr id="4" name="Oval 3"/>
+          <p:cNvPr id="4" name="deckgen:decor"/>
           <p:cNvSpPr/>
           <p:nvPr/>
         </p:nvSpPr>
@@ -13773,7 +13773,7 @@
       <p:grpSpPr/>
       <p:sp>
         <p:nvSpPr>
-          <p:cNvPr id="2" name="Oval 1"/>
+          <p:cNvPr id="2" name="deckgen:decor"/>
           <p:cNvSpPr/>
           <p:nvPr/>
         </p:nvSpPr>
@@ -13803,7 +13803,7 @@
       </p:sp>
       <p:sp>
         <p:nvSpPr>
-          <p:cNvPr id="3" name="Oval 2"/>
+          <p:cNvPr id="3" name="deckgen:decor"/>
           <p:cNvSpPr/>
           <p:nvPr/>
         </p:nvSpPr>
@@ -13833,7 +13833,7 @@
       </p:sp>
       <p:sp>
         <p:nvSpPr>
-          <p:cNvPr id="4" name="Oval 3"/>
+          <p:cNvPr id="4" name="deckgen:decor"/>
           <p:cNvSpPr/>
           <p:nvPr/>
         </p:nvSpPr>
@@ -14924,7 +14924,7 @@
       <p:grpSpPr/>
       <p:sp>
         <p:nvSpPr>
-          <p:cNvPr id="2" name="Oval 1"/>
+          <p:cNvPr id="2" name="deckgen:decor"/>
           <p:cNvSpPr/>
           <p:nvPr/>
         </p:nvSpPr>
@@ -14954,7 +14954,7 @@
       </p:sp>
       <p:sp>
         <p:nvSpPr>
-          <p:cNvPr id="3" name="Oval 2"/>
+          <p:cNvPr id="3" name="deckgen:decor"/>
           <p:cNvSpPr/>
           <p:nvPr/>
         </p:nvSpPr>
@@ -14984,7 +14984,7 @@
       </p:sp>
       <p:sp>
         <p:nvSpPr>
-          <p:cNvPr id="4" name="Oval 3"/>
+          <p:cNvPr id="4" name="deckgen:decor"/>
           <p:cNvSpPr/>
           <p:nvPr/>
         </p:nvSpPr>

</xml_diff>